<commit_message>
Update prompt examples to explicitly reference African American men and women
Slides 12, 13, 14, 15 now use prompts like "African American man graduating",
"African American woman studying", and suggest searching stock footage for
"African American students" and "Black excellence" representative clips.

Co-Authored-By: Claude Opus 4.6 <noreply@anthropic.com>
</commit_message>
<xml_diff>
--- a/AI-Creator-Lab-Deck.pptx
+++ b/AI-Creator-Lab-Deck.pptx
@@ -4005,11 +4005,11 @@
         <p:spPr>
           <a:xfrm>
             <a:off x="5080099" y="1498402"/>
-            <a:ext cx="3555950" cy="1072902"/>
+            <a:ext cx="3555950" cy="1225302"/>
           </a:xfrm>
           <a:prstGeom prst="roundRect">
             <a:avLst>
-              <a:gd name="adj" fmla="val 9470"/>
+              <a:gd name="adj" fmla="val 8292"/>
             </a:avLst>
           </a:prstGeom>
           <a:solidFill>
@@ -4083,7 +4083,7 @@
         <p:spPr>
           <a:xfrm>
             <a:off x="5276850" y="1942802"/>
-            <a:ext cx="3225698" cy="304800"/>
+            <a:ext cx="3225698" cy="457200"/>
           </a:xfrm>
           <a:prstGeom prst="rect">
             <a:avLst/>
@@ -4110,7 +4110,7 @@
                 <a:ea typeface="Arial" pitchFamily="34" charset="-122"/>
                 <a:cs typeface="Arial" pitchFamily="34" charset="-120"/>
               </a:rPr>
-              <a:t>"upbeat hip-hop song about graduating, confident vocals, 808 bass"</a:t>
+              <a:t>"upbeat hip-hop anthem about a young African American man graduating, confident vocals, 808 bass, celebratory vibe"</a:t>
             </a:r>
             <a:endParaRPr lang="en-US" sz="1100" dirty="0"/>
           </a:p>
@@ -4124,7 +4124,7 @@
         </p:nvSpPr>
         <p:spPr>
           <a:xfrm>
-            <a:off x="5080099" y="2672804"/>
+            <a:off x="5080099" y="2825204"/>
             <a:ext cx="3627069" cy="152400"/>
           </a:xfrm>
           <a:prstGeom prst="rect">
@@ -4416,11 +4416,11 @@
         <p:spPr>
           <a:xfrm>
             <a:off x="5080099" y="1498402"/>
-            <a:ext cx="3555950" cy="945952"/>
+            <a:ext cx="3555950" cy="1098352"/>
           </a:xfrm>
           <a:prstGeom prst="roundRect">
             <a:avLst>
-              <a:gd name="adj" fmla="val 10741"/>
+              <a:gd name="adj" fmla="val 9250"/>
             </a:avLst>
           </a:prstGeom>
           <a:solidFill>
@@ -4494,7 +4494,7 @@
         <p:spPr>
           <a:xfrm>
             <a:off x="5276850" y="1942802"/>
-            <a:ext cx="3225698" cy="304800"/>
+            <a:ext cx="3225698" cy="457200"/>
           </a:xfrm>
           <a:prstGeom prst="rect">
             <a:avLst/>
@@ -4518,7 +4518,7 @@
                 <a:ea typeface="Arial" pitchFamily="34" charset="-122"/>
                 <a:cs typeface="Arial" pitchFamily="34" charset="-120"/>
               </a:rPr>
-              <a:t>"photorealistic image of a student studying with holographic notes floating around them"</a:t>
+              <a:t>"photorealistic image of an African American woman studying with holographic notes floating around her, futuristic library setting"</a:t>
             </a:r>
             <a:endParaRPr lang="en-US" sz="1100" dirty="0"/>
           </a:p>
@@ -4785,11 +4785,11 @@
         <p:spPr>
           <a:xfrm>
             <a:off x="5080099" y="1498402"/>
-            <a:ext cx="3555950" cy="945952"/>
+            <a:ext cx="3555950" cy="1250752"/>
           </a:xfrm>
           <a:prstGeom prst="roundRect">
             <a:avLst>
-              <a:gd name="adj" fmla="val 10741"/>
+              <a:gd name="adj" fmla="val 8123"/>
             </a:avLst>
           </a:prstGeom>
           <a:solidFill>
@@ -4863,7 +4863,7 @@
         <p:spPr>
           <a:xfrm>
             <a:off x="5276850" y="1942802"/>
-            <a:ext cx="3225698" cy="304800"/>
+            <a:ext cx="3225698" cy="609600"/>
           </a:xfrm>
           <a:prstGeom prst="rect">
             <a:avLst/>
@@ -4887,7 +4887,7 @@
                 <a:ea typeface="Arial" pitchFamily="34" charset="-122"/>
                 <a:cs typeface="Arial" pitchFamily="34" charset="-120"/>
               </a:rPr>
-              <a:t>Use your storyboard sketch from the Creator Blueprint!</a:t>
+              <a:t>Use your storyboard sketch from the Creator Blueprint! Search stock footage for "African American students" or "Black excellence" to find representative clips.</a:t>
             </a:r>
             <a:endParaRPr lang="en-US" sz="1100" dirty="0"/>
           </a:p>
@@ -5006,11 +5006,11 @@
         <p:spPr>
           <a:xfrm>
             <a:off x="381000" y="980926"/>
-            <a:ext cx="8382000" cy="580727"/>
+            <a:ext cx="8382000" cy="733127"/>
           </a:xfrm>
           <a:prstGeom prst="roundRect">
             <a:avLst>
-              <a:gd name="adj" fmla="val 13121"/>
+              <a:gd name="adj" fmla="val 10394"/>
             </a:avLst>
           </a:prstGeom>
           <a:solidFill>
@@ -5038,7 +5038,7 @@
         <p:spPr>
           <a:xfrm>
             <a:off x="404813" y="980926"/>
-            <a:ext cx="0" cy="580727"/>
+            <a:ext cx="0" cy="733127"/>
           </a:xfrm>
           <a:prstGeom prst="line">
             <a:avLst/>
@@ -5060,7 +5060,7 @@
         </p:nvSpPr>
         <p:spPr>
           <a:xfrm>
-            <a:off x="606326" y="1093440"/>
+            <a:off x="606326" y="1169640"/>
             <a:ext cx="355550" cy="355550"/>
           </a:xfrm>
           <a:prstGeom prst="roundRect">
@@ -5092,7 +5092,7 @@
         </p:nvSpPr>
         <p:spPr>
           <a:xfrm>
-            <a:off x="733626" y="1166366"/>
+            <a:off x="733626" y="1242566"/>
             <a:ext cx="100950" cy="209550"/>
           </a:xfrm>
           <a:prstGeom prst="rect">
@@ -5174,7 +5174,7 @@
         <p:spPr>
           <a:xfrm>
             <a:off x="1114276" y="1307753"/>
-            <a:ext cx="7620444" cy="152400"/>
+            <a:ext cx="7620444" cy="304800"/>
           </a:xfrm>
           <a:prstGeom prst="rect">
             <a:avLst/>
@@ -5198,7 +5198,7 @@
                 <a:ea typeface="Arial" pitchFamily="34" charset="-122"/>
                 <a:cs typeface="Arial" pitchFamily="34" charset="-120"/>
               </a:rPr>
-              <a:t>Don't say "make a song." Say "upbeat pop song about summer, female vocals, 120 BPM"</a:t>
+              <a:t>Don't say "make a song." Say "upbeat R&amp;B song about an African American woman chasing her dreams, soulful vocals, 90 BPM"</a:t>
             </a:r>
             <a:endParaRPr lang="en-US" sz="1100" dirty="0"/>
           </a:p>
@@ -5212,7 +5212,7 @@
         </p:nvSpPr>
         <p:spPr>
           <a:xfrm>
-            <a:off x="381000" y="1663154"/>
+            <a:off x="381000" y="1815554"/>
             <a:ext cx="8382000" cy="580727"/>
           </a:xfrm>
           <a:prstGeom prst="roundRect">
@@ -5244,7 +5244,7 @@
         </p:nvSpPr>
         <p:spPr>
           <a:xfrm>
-            <a:off x="404813" y="1663154"/>
+            <a:off x="404813" y="1815554"/>
             <a:ext cx="0" cy="580727"/>
           </a:xfrm>
           <a:prstGeom prst="line">
@@ -5267,7 +5267,7 @@
         </p:nvSpPr>
         <p:spPr>
           <a:xfrm>
-            <a:off x="606326" y="1775668"/>
+            <a:off x="606326" y="1928068"/>
             <a:ext cx="355550" cy="355550"/>
           </a:xfrm>
           <a:prstGeom prst="roundRect">
@@ -5299,7 +5299,7 @@
         </p:nvSpPr>
         <p:spPr>
           <a:xfrm>
-            <a:off x="733626" y="1848594"/>
+            <a:off x="733626" y="2000994"/>
             <a:ext cx="100950" cy="209550"/>
           </a:xfrm>
           <a:prstGeom prst="rect">
@@ -5338,7 +5338,7 @@
         </p:nvSpPr>
         <p:spPr>
           <a:xfrm>
-            <a:off x="1114276" y="1764655"/>
+            <a:off x="1114276" y="1917055"/>
             <a:ext cx="7620444" cy="200025"/>
           </a:xfrm>
           <a:prstGeom prst="rect">
@@ -5380,7 +5380,7 @@
         </p:nvSpPr>
         <p:spPr>
           <a:xfrm>
-            <a:off x="1114276" y="1989981"/>
+            <a:off x="1114276" y="2142381"/>
             <a:ext cx="7620444" cy="152400"/>
           </a:xfrm>
           <a:prstGeom prst="rect">
@@ -5405,7 +5405,7 @@
                 <a:ea typeface="Arial" pitchFamily="34" charset="-122"/>
                 <a:cs typeface="Arial" pitchFamily="34" charset="-120"/>
               </a:rPr>
-              <a:t>Add mood words: dreamy, energetic, dark, nostalgic</a:t>
+              <a:t>Add mood words: dreamy, energetic, dark, nostalgic, empowering</a:t>
             </a:r>
             <a:endParaRPr lang="en-US" sz="1100" dirty="0"/>
           </a:p>
@@ -5419,7 +5419,7 @@
         </p:nvSpPr>
         <p:spPr>
           <a:xfrm>
-            <a:off x="381000" y="2345382"/>
+            <a:off x="381000" y="2497782"/>
             <a:ext cx="8382000" cy="580727"/>
           </a:xfrm>
           <a:prstGeom prst="roundRect">
@@ -5451,7 +5451,7 @@
         </p:nvSpPr>
         <p:spPr>
           <a:xfrm>
-            <a:off x="404813" y="2345382"/>
+            <a:off x="404813" y="2497782"/>
             <a:ext cx="0" cy="580727"/>
           </a:xfrm>
           <a:prstGeom prst="line">
@@ -5474,7 +5474,7 @@
         </p:nvSpPr>
         <p:spPr>
           <a:xfrm>
-            <a:off x="606326" y="2457896"/>
+            <a:off x="606326" y="2610296"/>
             <a:ext cx="355550" cy="355550"/>
           </a:xfrm>
           <a:prstGeom prst="roundRect">
@@ -5506,7 +5506,7 @@
         </p:nvSpPr>
         <p:spPr>
           <a:xfrm>
-            <a:off x="733626" y="2530822"/>
+            <a:off x="733626" y="2683222"/>
             <a:ext cx="100950" cy="209550"/>
           </a:xfrm>
           <a:prstGeom prst="rect">
@@ -5545,7 +5545,7 @@
         </p:nvSpPr>
         <p:spPr>
           <a:xfrm>
-            <a:off x="1114276" y="2446883"/>
+            <a:off x="1114276" y="2599283"/>
             <a:ext cx="7620444" cy="200025"/>
           </a:xfrm>
           <a:prstGeom prst="rect">
@@ -5587,7 +5587,7 @@
         </p:nvSpPr>
         <p:spPr>
           <a:xfrm>
-            <a:off x="1114276" y="2672209"/>
+            <a:off x="1114276" y="2824609"/>
             <a:ext cx="7620444" cy="152400"/>
           </a:xfrm>
           <a:prstGeom prst="rect">
@@ -5626,7 +5626,7 @@
         </p:nvSpPr>
         <p:spPr>
           <a:xfrm>
-            <a:off x="381000" y="3027611"/>
+            <a:off x="381000" y="3180011"/>
             <a:ext cx="8382000" cy="580727"/>
           </a:xfrm>
           <a:prstGeom prst="roundRect">
@@ -5658,7 +5658,7 @@
         </p:nvSpPr>
         <p:spPr>
           <a:xfrm>
-            <a:off x="404813" y="3027611"/>
+            <a:off x="404813" y="3180011"/>
             <a:ext cx="0" cy="580727"/>
           </a:xfrm>
           <a:prstGeom prst="line">
@@ -5681,7 +5681,7 @@
         </p:nvSpPr>
         <p:spPr>
           <a:xfrm>
-            <a:off x="606326" y="3140125"/>
+            <a:off x="606326" y="3292525"/>
             <a:ext cx="355550" cy="355550"/>
           </a:xfrm>
           <a:prstGeom prst="roundRect">
@@ -5713,7 +5713,7 @@
         </p:nvSpPr>
         <p:spPr>
           <a:xfrm>
-            <a:off x="733626" y="3213050"/>
+            <a:off x="733626" y="3365450"/>
             <a:ext cx="100950" cy="209550"/>
           </a:xfrm>
           <a:prstGeom prst="rect">
@@ -5752,7 +5752,7 @@
         </p:nvSpPr>
         <p:spPr>
           <a:xfrm>
-            <a:off x="1114276" y="3129111"/>
+            <a:off x="1114276" y="3281511"/>
             <a:ext cx="7620444" cy="200025"/>
           </a:xfrm>
           <a:prstGeom prst="rect">
@@ -5794,7 +5794,7 @@
         </p:nvSpPr>
         <p:spPr>
           <a:xfrm>
-            <a:off x="1114276" y="3354437"/>
+            <a:off x="1114276" y="3506837"/>
             <a:ext cx="7620444" cy="152400"/>
           </a:xfrm>
           <a:prstGeom prst="rect">
@@ -5833,7 +5833,7 @@
         </p:nvSpPr>
         <p:spPr>
           <a:xfrm>
-            <a:off x="381000" y="3709839"/>
+            <a:off x="381000" y="3862239"/>
             <a:ext cx="8382000" cy="580727"/>
           </a:xfrm>
           <a:prstGeom prst="roundRect">
@@ -5865,7 +5865,7 @@
         </p:nvSpPr>
         <p:spPr>
           <a:xfrm>
-            <a:off x="404813" y="3709839"/>
+            <a:off x="404813" y="3862239"/>
             <a:ext cx="0" cy="580727"/>
           </a:xfrm>
           <a:prstGeom prst="line">
@@ -5888,7 +5888,7 @@
         </p:nvSpPr>
         <p:spPr>
           <a:xfrm>
-            <a:off x="606326" y="3822353"/>
+            <a:off x="606326" y="3974753"/>
             <a:ext cx="355550" cy="355550"/>
           </a:xfrm>
           <a:prstGeom prst="roundRect">
@@ -5920,7 +5920,7 @@
         </p:nvSpPr>
         <p:spPr>
           <a:xfrm>
-            <a:off x="733626" y="3895279"/>
+            <a:off x="733626" y="4047679"/>
             <a:ext cx="100950" cy="209550"/>
           </a:xfrm>
           <a:prstGeom prst="rect">
@@ -5959,7 +5959,7 @@
         </p:nvSpPr>
         <p:spPr>
           <a:xfrm>
-            <a:off x="1114276" y="3811339"/>
+            <a:off x="1114276" y="3963739"/>
             <a:ext cx="7620444" cy="200025"/>
           </a:xfrm>
           <a:prstGeom prst="rect">
@@ -6001,7 +6001,7 @@
         </p:nvSpPr>
         <p:spPr>
           <a:xfrm>
-            <a:off x="1114276" y="4036665"/>
+            <a:off x="1114276" y="4189065"/>
             <a:ext cx="7620444" cy="152400"/>
           </a:xfrm>
           <a:prstGeom prst="rect">

</xml_diff>